<commit_message>
Apply copy and tone pass to Q2 2026 deck
Feedback from review, applied across all ten slides:

- Executive summary now leads with a positive metric. The mentions decline tile
  is replaced by "11 of 16", the priority questions where Komprise sits inside
  Google's AI answer.
- Second person removed throughout. The deck now says Komprise, us or our.
- Em dashes removed everywhere, including the slide footer. Commas, colons and
  full stops instead. Removed the comma before "and".
- Metrics still in flight are framed as in progress rather than as failures.
  The mentions series moves from red to amber to match.

Verified mechanically against the rendered PDF text: zero em dashes, zero
second-person references, zero comma-before-and occurrences.

Co-Authored-By: Claude Opus 5 <noreply@anthropic.com>
Claude-Session: https://claude.ai/code/session_01Qb9Qq8GcnmrwCpYXA3jWR9
</commit_message>
<xml_diff>
--- a/Komprise_GEO_SEO_Q2_2026.pptx
+++ b/Komprise_GEO_SEO_Q2_2026.pptx
@@ -318,14 +318,14 @@
           <c:spPr>
             <a:ln w="34925">
               <a:solidFill>
-                <a:srgbClr val="B03A2E"/>
+                <a:srgbClr val="C88A1E"/>
               </a:solidFill>
             </a:ln>
           </c:spPr>
           <c:marker>
             <c:spPr>
               <a:solidFill>
-                <a:srgbClr val="B03A2E"/>
+                <a:srgbClr val="C88A1E"/>
               </a:solidFill>
               <a:ln>
                 <a:solidFill>
@@ -4309,7 +4309,7 @@
                 </a:solidFill>
                 <a:latin typeface="Open Sans"/>
               </a:rPr>
-              <a:t>Q2 2026  ·  April – June</a:t>
+              <a:t>Q2 2026  ·  April to June</a:t>
             </a:r>
           </a:p>
         </p:txBody>
@@ -4412,7 +4412,7 @@
                 </a:solidFill>
                 <a:latin typeface="Open Sans"/>
               </a:rPr>
-              <a:t>Komprise today — and what</a:t>
+              <a:t>Komprise today and what</a:t>
             </a:r>
           </a:p>
           <a:p>
@@ -4536,7 +4536,7 @@
                 </a:solidFill>
                 <a:latin typeface="Open Sans"/>
               </a:rPr>
-              <a:t>Be the answer for AI-ready data — unstructured data for AI, AI data management.</a:t>
+              <a:t>Be the answer for AI-ready data: unstructured data for AI, AI data management.</a:t>
             </a:r>
           </a:p>
           <a:p>
@@ -4555,7 +4555,7 @@
                 </a:solidFill>
                 <a:latin typeface="Open Sans"/>
               </a:rPr>
-              <a:t>Be the answer for storage price hikes — tiering, cost savings, NetApp, Dell, Everpure.</a:t>
+              <a:t>Be the answer for storage price hikes: tiering, cost savings, NetApp, Dell, Everpure.</a:t>
             </a:r>
           </a:p>
         </p:txBody>
@@ -4811,7 +4811,7 @@
                 </a:solidFill>
                 <a:latin typeface="Open Sans"/>
               </a:rPr>
-              <a:t>Five priorities, weighted to the gap the data has exposed</a:t>
+              <a:t>Five priorities, weighted to what the data now shows</a:t>
             </a:r>
           </a:p>
         </p:txBody>
@@ -5071,7 +5071,7 @@
                 </a:solidFill>
                 <a:latin typeface="Open Sans"/>
               </a:rPr>
-              <a:t>We hold the specific technical questions and lose the broad ones. Getting AI data management, AI data platform and AI data preparation into the AI answer is the highest-value work available.</a:t>
+              <a:t>Komprise holds the specific technical questions while the broad ones are still open. Getting AI data management, AI data platform and AI data preparation into the AI answer is the highest-value work available.</a:t>
             </a:r>
           </a:p>
         </p:txBody>
@@ -5331,7 +5331,7 @@
                 </a:solidFill>
                 <a:latin typeface="Open Sans"/>
               </a:rPr>
-              <a:t>Content has taken citations as far as it can. Only independent coverage — analysts and trade press — makes a model say our name, and mentions are the metric still moving the wrong way.</a:t>
+              <a:t>Content has taken citations a long way. Independent coverage from analysts and trade press is what makes a model say the name. That programme is now getting underway.</a:t>
             </a:r>
           </a:p>
         </p:txBody>
@@ -5591,7 +5591,7 @@
                 </a:solidFill>
                 <a:latin typeface="Open Sans"/>
               </a:rPr>
-              <a:t>Structured data is still missing from most blog posts and older template pages still carry cost-led copy. These are single-template fixes with disproportionate return.</a:t>
+              <a:t>Structured data is still to be added on most blog posts and older template pages still carry cost-led copy. These are single-template fixes with disproportionate return.</a:t>
             </a:r>
           </a:p>
         </p:txBody>
@@ -5851,7 +5851,7 @@
                 </a:solidFill>
                 <a:latin typeface="Open Sans"/>
               </a:rPr>
-              <a:t>It is our strongest position in AI answers and it is now being contested by a much larger rebranded competitor. Holding it protects the pipeline story.</a:t>
+              <a:t>This is the strongest position Komprise holds in AI answers and a much larger rebranded competitor is now contesting it. Holding it protects the pipeline story.</a:t>
             </a:r>
           </a:p>
         </p:txBody>
@@ -6241,7 +6241,7 @@
                 </a:solidFill>
                 <a:latin typeface="Open Sans"/>
               </a:rPr>
-              <a:t>How we will know it worked: Komprise inside the AI answer on the AI-lane category terms, and the mentions line turning back up.</a:t>
+              <a:t>How we will know it worked: Komprise inside the AI answer on the AI-lane category terms and the mentions line climbing.</a:t>
             </a:r>
           </a:p>
         </p:txBody>
@@ -6283,7 +6283,7 @@
                 </a:solidFill>
                 <a:latin typeface="Open Sans"/>
               </a:rPr>
-              <a:t>Komprise  —  GEO &amp; SEO Performance, Q2 2026</a:t>
+              <a:t>Komprise  ·  GEO &amp; SEO Performance, Q2 2026</a:t>
             </a:r>
           </a:p>
         </p:txBody>
@@ -6539,7 +6539,7 @@
                 </a:solidFill>
                 <a:latin typeface="Open Sans"/>
               </a:rPr>
-              <a:t>Q2 2026 — where we stand on being seen as an AI company</a:t>
+              <a:t>Q2 2026: where we stand on being seen as an AI company</a:t>
             </a:r>
           </a:p>
         </p:txBody>
@@ -6821,7 +6821,7 @@
             <a:avLst/>
           </a:prstGeom>
           <a:solidFill>
-            <a:srgbClr val="B03A2E"/>
+            <a:srgbClr val="7A9905"/>
           </a:solidFill>
           <a:ln>
             <a:noFill/>
@@ -6881,13 +6881,13 @@
               </a:spcAft>
             </a:pPr>
             <a:r>
-              <a:rPr sz="3000" b="1">
-                <a:solidFill>
-                  <a:srgbClr val="B03A2E"/>
-                </a:solidFill>
-                <a:latin typeface="Open Sans"/>
-              </a:rPr>
-              <a:t>‒72%</a:t>
+              <a:rPr sz="2600" b="1">
+                <a:solidFill>
+                  <a:srgbClr val="7A9905"/>
+                </a:solidFill>
+                <a:latin typeface="Open Sans"/>
+              </a:rPr>
+              <a:t>11 of 16</a:t>
             </a:r>
           </a:p>
         </p:txBody>
@@ -6929,7 +6929,7 @@
                 </a:solidFill>
                 <a:latin typeface="Open Sans"/>
               </a:rPr>
-              <a:t>Name Mentions</a:t>
+              <a:t>Priority Questions Won</a:t>
             </a:r>
           </a:p>
         </p:txBody>
@@ -6971,7 +6971,7 @@
                 </a:solidFill>
                 <a:latin typeface="Open Sans"/>
               </a:rPr>
-              <a:t>Being cited is not the same as being named. This is the gap.</a:t>
+              <a:t>Komprise sits inside Google's AI answer on 11 of the 16 questions across both lanes.</a:t>
             </a:r>
           </a:p>
         </p:txBody>
@@ -7187,7 +7187,7 @@
                 </a:solidFill>
                 <a:latin typeface="Open Sans"/>
               </a:rPr>
-              <a:t>Up 128 across the quarter, and up 66 in the top three.</a:t>
+              <a:t>Up 128 across the quarter and up 66 in the top three.</a:t>
             </a:r>
           </a:p>
         </p:txBody>
@@ -7403,7 +7403,7 @@
                 </a:solidFill>
                 <a:latin typeface="Open Sans"/>
               </a:rPr>
-              <a:t>Up from 41%. People read the AI answer, then type us in.</a:t>
+              <a:t>Up from 41%. People read the AI answer then come straight to Komprise.</a:t>
             </a:r>
           </a:p>
         </p:txBody>
@@ -7575,7 +7575,7 @@
                 </a:solidFill>
                 <a:latin typeface="Open Sans"/>
               </a:rPr>
-              <a:t>We already win the storage-cost lane inside AI answers. On tiering and storage-cost questions, Google's AI answer names Komprise first.</a:t>
+              <a:t>Komprise already wins the storage-cost lane inside AI answers. On tiering and storage-cost questions, Google's AI answer names Komprise first.</a:t>
             </a:r>
           </a:p>
         </p:txBody>
@@ -7661,7 +7661,7 @@
                 </a:solidFill>
                 <a:latin typeface="Open Sans"/>
               </a:rPr>
-              <a:t>We do not yet win the AI-data lane. On “AI data management” — the term buyers start with — we sit at position 15 and are absent from the AI answer entirely.</a:t>
+              <a:t>The AI-data lane is half built. Komprise is the AI answer on the specific technical questions, while the broad category terms buyers start with are still in progress.</a:t>
             </a:r>
           </a:p>
         </p:txBody>
@@ -7747,7 +7747,7 @@
                 </a:solidFill>
                 <a:latin typeface="Open Sans"/>
               </a:rPr>
-              <a:t>Citations are rising, mentions are falling. Our content earns links in AI answers; only third-party coverage makes the model say our name.</a:t>
+              <a:t>Citations are climbing steadily. Cited pages are up 19% and 2.1K AI answers a month now point to a Komprise page. Building name mentions through earned coverage is the next phase.</a:t>
             </a:r>
           </a:p>
         </p:txBody>
@@ -7833,7 +7833,7 @@
                 </a:solidFill>
                 <a:latin typeface="Open Sans"/>
               </a:rPr>
-              <a:t>The traffic mix is changing underneath us. Direct has overtaken organic search — the visible proof that AI answers are doing the discovery.</a:t>
+              <a:t>The traffic mix is shifting. Direct has overtaken organic search, which is the visible proof that AI answers are doing the discovery.</a:t>
             </a:r>
           </a:p>
         </p:txBody>
@@ -7963,7 +7963,7 @@
                 </a:solidFill>
                 <a:latin typeface="Open Sans"/>
               </a:rPr>
-              <a:t>In short: the storage story is won in AI search. The AI story is half-built — and that is where Q3 goes.</a:t>
+              <a:t>In short: the storage story is won in AI search. The AI story is half built and that is where Q3 goes.</a:t>
             </a:r>
           </a:p>
         </p:txBody>
@@ -8005,7 +8005,7 @@
                 </a:solidFill>
                 <a:latin typeface="Open Sans"/>
               </a:rPr>
-              <a:t>Komprise  —  GEO &amp; SEO Performance, Q2 2026</a:t>
+              <a:t>Komprise  ·  GEO &amp; SEO Performance, Q2 2026</a:t>
             </a:r>
           </a:p>
         </p:txBody>
@@ -8261,7 +8261,7 @@
                 </a:solidFill>
                 <a:latin typeface="Open Sans"/>
               </a:rPr>
-              <a:t>What Decides Whether an AI Names You</a:t>
+              <a:t>What Decides Whether an AI Names Komprise</a:t>
             </a:r>
           </a:p>
         </p:txBody>
@@ -8303,7 +8303,7 @@
                 </a:solidFill>
                 <a:latin typeface="Open Sans"/>
               </a:rPr>
-              <a:t>Three things, and only the first is your own website</a:t>
+              <a:t>Three things. Only the first one is our own website.</a:t>
             </a:r>
           </a:p>
         </p:txBody>
@@ -8563,7 +8563,7 @@
                 </a:solidFill>
                 <a:latin typeface="Open Sans"/>
               </a:rPr>
-              <a:t>AI crawlers read plain text and structured data. A page with no schema, or one that blocks the crawler, effectively does not exist to the model — however good the writing is.</a:t>
+              <a:t>AI crawlers read plain text and structured data. A page with no schema, or one that blocks the crawler, effectively does not exist to the model, however good the writing is.</a:t>
             </a:r>
           </a:p>
         </p:txBody>
@@ -9255,7 +9255,7 @@
                 </a:solidFill>
                 <a:latin typeface="Open Sans"/>
               </a:rPr>
-              <a:t>A citation is a link inside the answer. A mention is the model actually saying “Komprise”. Citations follow good content. Mentions follow earned coverage — analysts, press, independent authority.</a:t>
+              <a:t>A citation is a link inside the answer. A mention is the model actually saying “Komprise”. Citations follow good content. Mentions follow earned coverage: analysts, press and independent authority.</a:t>
             </a:r>
           </a:p>
         </p:txBody>
@@ -9341,7 +9341,7 @@
                 </a:solidFill>
                 <a:latin typeface="Open Sans"/>
               </a:rPr>
-              <a:t>Open: this is the metric still moving the wrong way.</a:t>
+              <a:t>In progress: building the coverage that earns mentions.</a:t>
             </a:r>
           </a:p>
         </p:txBody>
@@ -9492,7 +9492,7 @@
                 </a:solidFill>
                 <a:latin typeface="Open Sans"/>
               </a:rPr>
-              <a:t>In July we asked ChatGPT “How to address rising enterprise storage costs — please cite sources.” It answered with Microsoft Learn, AWS, TechTarget and an academic paper. No vendor content at all, including ours — even though we have strong, well-sourced pages on exactly that question. When a buyer asks for sources, the model reaches for independent publications over any vendor. That single behaviour is why the next lever is third-party placement, not more pages.</a:t>
+              <a:t>In July we asked ChatGPT “How to address rising enterprise storage costs, please cite sources.” It answered with Microsoft Learn, AWS, TechTarget and an academic paper. No vendor content at all, including ours, even though Komprise has strong well-sourced pages on exactly that question. When a buyer asks for sources, the model reaches for independent publications over any vendor. That single behaviour is why the next lever is third-party placement rather than more pages.</a:t>
             </a:r>
           </a:p>
         </p:txBody>
@@ -9534,7 +9534,7 @@
                 </a:solidFill>
                 <a:latin typeface="Open Sans"/>
               </a:rPr>
-              <a:t>Komprise  —  GEO &amp; SEO Performance, Q2 2026</a:t>
+              <a:t>Komprise  ·  GEO &amp; SEO Performance, Q2 2026</a:t>
             </a:r>
           </a:p>
         </p:txBody>
@@ -10090,7 +10090,7 @@
                 </a:solidFill>
                 <a:latin typeface="Open Sans"/>
               </a:rPr>
-              <a:t>More than 20 new AI glossary pages published to claim the language buyers and models use — AI Data Platform, AI-Ready Data, AI Data Ingestion, AI Data Curation, Vector Embeddings, Synthetic Data, AI Token, Tokenization.</a:t>
+              <a:t>More than 20 new AI glossary pages published to claim the language buyers and models use: AI Data Platform, AI-Ready Data, AI Data Ingestion, AI Data Curation, Vector Embeddings, Synthetic Data, AI Token and Tokenization.</a:t>
             </a:r>
           </a:p>
         </p:txBody>
@@ -10606,7 +10606,7 @@
                 </a:solidFill>
                 <a:latin typeface="Open Sans"/>
               </a:rPr>
-              <a:t>AI crawlers explicitly admitted in robots.txt — previously two major assistants could not read the site at all.</a:t>
+              <a:t>AI crawlers explicitly admitted in robots.txt. Two major assistants previously could not read the site at all.</a:t>
             </a:r>
           </a:p>
         </p:txBody>
@@ -10950,7 +10950,7 @@
                 </a:solidFill>
                 <a:latin typeface="Open Sans"/>
               </a:rPr>
-              <a:t>Legacy cost-led meta template retired from 58 pages; duplicate blog index resolved and sitemap cleaned.</a:t>
+              <a:t>Legacy cost-led meta template retired from 58 pages. Duplicate blog index resolved and sitemap cleaned.</a:t>
             </a:r>
           </a:p>
         </p:txBody>
@@ -11080,7 +11080,7 @@
                 </a:solidFill>
                 <a:latin typeface="Open Sans"/>
               </a:rPr>
-              <a:t>Early proof it works: product names we deliberately repeated across trusted sites — Transparent Move Technology, Global Metadatabase — are now being repeated back to us by AI assistants, unprompted.</a:t>
+              <a:t>Early proof it works: product names Komprise deliberately repeated across trusted sites, Transparent Move Technology and Global Metadatabase, are now being repeated back by AI assistants, unprompted.</a:t>
             </a:r>
           </a:p>
         </p:txBody>
@@ -11122,7 +11122,7 @@
                 </a:solidFill>
                 <a:latin typeface="Open Sans"/>
               </a:rPr>
-              <a:t>Komprise  —  GEO &amp; SEO Performance, Q2 2026</a:t>
+              <a:t>Komprise  ·  GEO &amp; SEO Performance, Q2 2026</a:t>
             </a:r>
           </a:p>
         </p:txBody>
@@ -15654,7 +15654,7 @@
                 </a:solidFill>
                 <a:latin typeface="Open Sans"/>
               </a:rPr>
-              <a:t>rising storage costs — cite sources</a:t>
+              <a:t>rising storage costs, cite sources</a:t>
             </a:r>
           </a:p>
         </p:txBody>
@@ -15914,7 +15914,7 @@
                 </a:solidFill>
                 <a:latin typeface="Open Sans"/>
               </a:rPr>
-              <a:t>The verdict: on storage costs we are already the answer — seven of eight questions put Komprise inside Google's AI answer, most of them first. On AI-ready data we are half-built: we win the specific technical questions, and we lose the broad category terms a buyer actually starts with. Winning those is the work that remains.</a:t>
+              <a:t>The verdict: on storage costs Komprise is already the answer. Seven of eight questions place Komprise inside Google's AI answer, most of them first. On AI-ready data the work is half done. Komprise wins the specific technical questions while the broad category terms a buyer starts with are still in progress. Winning those is the focus from here.</a:t>
             </a:r>
           </a:p>
         </p:txBody>
@@ -15956,7 +15956,7 @@
                 </a:solidFill>
                 <a:latin typeface="Open Sans"/>
               </a:rPr>
-              <a:t>Komprise  —  GEO &amp; SEO Performance, Q2 2026</a:t>
+              <a:t>Komprise  ·  GEO &amp; SEO Performance, Q2 2026</a:t>
             </a:r>
           </a:p>
         </p:txBody>
@@ -16212,7 +16212,7 @@
                 </a:solidFill>
                 <a:latin typeface="Open Sans"/>
               </a:rPr>
-              <a:t>Citations Are Rising. Mentions Are the Soft Spot.</a:t>
+              <a:t>Citations Are Rising. Mentions Are Next.</a:t>
             </a:r>
           </a:p>
         </p:txBody>
@@ -16254,7 +16254,7 @@
                 </a:solidFill>
                 <a:latin typeface="Open Sans"/>
               </a:rPr>
-              <a:t>Jan → Jun 2026:   Citations +20%   ·   Cited Pages +19%   ·   Mentions ‒72%</a:t>
+              <a:t>Jan to Jun 2026:   Citations +20%   ·   Cited Pages +19%   ·   Mentions still building</a:t>
             </a:r>
           </a:p>
         </p:txBody>
@@ -16314,7 +16314,7 @@
                 </a:solidFill>
                 <a:latin typeface="Open Sans"/>
               </a:rPr>
-              <a:t>Q2 is the steep part of all three lines. Monthly shape reproduced from the June metrics report; January and June values are exact.</a:t>
+              <a:t>Q2 is the steep part of all three lines. Monthly shape reproduced from the June metrics report. January and June values are exact.</a:t>
             </a:r>
           </a:p>
         </p:txBody>
@@ -16530,7 +16530,7 @@
                 </a:solidFill>
                 <a:latin typeface="Open Sans"/>
               </a:rPr>
-              <a:t>AI answers pointing to a Komprise page. Our content optimisation work landing.</a:t>
+              <a:t>AI answers pointing to a Komprise page. The content optimisation work landing.</a:t>
             </a:r>
           </a:p>
         </p:txBody>
@@ -16746,7 +16746,7 @@
                 </a:solidFill>
                 <a:latin typeface="Open Sans"/>
               </a:rPr>
-              <a:t>Distinct pages being cited. Broad surface area, and holding up.</a:t>
+              <a:t>Distinct pages being cited. Broad surface area and holding up.</a:t>
             </a:r>
           </a:p>
         </p:txBody>
@@ -16812,7 +16812,7 @@
             <a:avLst/>
           </a:prstGeom>
           <a:solidFill>
-            <a:srgbClr val="B03A2E"/>
+            <a:srgbClr val="C88A1E"/>
           </a:solidFill>
           <a:ln>
             <a:noFill/>
@@ -16874,7 +16874,7 @@
             <a:r>
               <a:rPr sz="2600" b="1">
                 <a:solidFill>
-                  <a:srgbClr val="B03A2E"/>
+                  <a:srgbClr val="C88A1E"/>
                 </a:solidFill>
                 <a:latin typeface="Open Sans"/>
               </a:rPr>
@@ -16962,7 +16962,7 @@
                 </a:solidFill>
                 <a:latin typeface="Open Sans"/>
               </a:rPr>
-              <a:t>The model saying “Komprise”. Down sharply — a coverage gap, not a content gap.</a:t>
+              <a:t>The model saying “Komprise”. Earned coverage is the lever here and that work is underway.</a:t>
             </a:r>
           </a:p>
         </p:txBody>
@@ -17004,7 +17004,7 @@
                 </a:solidFill>
                 <a:latin typeface="Open Sans"/>
               </a:rPr>
-              <a:t>Komprise  —  GEO &amp; SEO Performance, Q2 2026</a:t>
+              <a:t>Komprise  ·  GEO &amp; SEO Performance, Q2 2026</a:t>
             </a:r>
           </a:p>
         </p:txBody>
@@ -17362,7 +17362,7 @@
                 </a:solidFill>
                 <a:latin typeface="Open Sans"/>
               </a:rPr>
-              <a:t>Q1 closed at 1,387 keywords in the top 10. Q2 closed at 1,515 — and the top-three band, the positions that actually get read, grew fastest.</a:t>
+              <a:t>Q1 closed at 1,387 keywords in the top 10. Q2 closed at 1,515. The top-three band, the positions that actually get read, grew fastest.</a:t>
             </a:r>
           </a:p>
         </p:txBody>
@@ -17945,7 +17945,7 @@
                 </a:solidFill>
                 <a:latin typeface="Open Sans"/>
               </a:rPr>
-              <a:t>Two years ago we held 510 top-10 keywords. We now hold 1,515. This is the compounding base that AI answers draw from — models cite what already ranks.</a:t>
+              <a:t>Two years ago Komprise held 510 top-10 keywords. That is now 1,515. This is the compounding base AI answers draw from, because models cite what already ranks.</a:t>
             </a:r>
           </a:p>
         </p:txBody>
@@ -17987,7 +17987,7 @@
                 </a:solidFill>
                 <a:latin typeface="Open Sans"/>
               </a:rPr>
-              <a:t>Komprise  —  GEO &amp; SEO Performance, Q2 2026</a:t>
+              <a:t>Komprise  ·  GEO &amp; SEO Performance, Q2 2026</a:t>
             </a:r>
           </a:p>
         </p:txBody>
@@ -18285,7 +18285,7 @@
                 </a:solidFill>
                 <a:latin typeface="Open Sans"/>
               </a:rPr>
-              <a:t>Monthly sessions — the visible signature of zero-click search and direct brand discovery</a:t>
+              <a:t>Monthly sessions, the visible signature of zero-click search and direct brand discovery</a:t>
             </a:r>
           </a:p>
         </p:txBody>
@@ -18345,7 +18345,7 @@
                 </a:solidFill>
                 <a:latin typeface="Open Sans"/>
               </a:rPr>
-              <a:t>Total sessions dipped into June. That fall sits almost entirely in email campaign volume, not in search — organic and direct are the lines that describe how people find us.</a:t>
+              <a:t>Total sessions dipped into June. That fall sits almost entirely in email campaign volume rather than search. Organic and direct are the lines that describe how people find Komprise.</a:t>
             </a:r>
           </a:p>
         </p:txBody>
@@ -18496,7 +18496,7 @@
                 </a:solidFill>
                 <a:latin typeface="Open Sans"/>
               </a:rPr>
-              <a:t>Direct grew from 41% of sessions in Q1 to 52% in Q2, while organic search fell. People are reading the answer in an AI or search result, then arriving by typing us in.</a:t>
+              <a:t>Direct grew from 41% of sessions in Q1 to 52% in Q2 while organic search fell. People are reading the answer in an AI or search result, then arriving by typing Komprise in.</a:t>
             </a:r>
           </a:p>
         </p:txBody>
@@ -18647,7 +18647,7 @@
                 </a:solidFill>
                 <a:latin typeface="Open Sans"/>
               </a:rPr>
-              <a:t>A falling click count is not a falling audience. AI answers resolve the question on the results page, so the visit only happens once someone decides they want us specifically. That is brand, and it is showing up in the data.</a:t>
+              <a:t>A falling click count is not a falling audience. AI answers resolve the question on the results page, so the visit only happens once someone decides they want Komprise specifically. That is brand showing up in the data.</a:t>
             </a:r>
           </a:p>
         </p:txBody>
@@ -18689,7 +18689,7 @@
                 </a:solidFill>
                 <a:latin typeface="Open Sans"/>
               </a:rPr>
-              <a:t>Komprise  —  GEO &amp; SEO Performance, Q2 2026</a:t>
+              <a:t>Komprise  ·  GEO &amp; SEO Performance, Q2 2026</a:t>
             </a:r>
           </a:p>
         </p:txBody>
@@ -21209,7 +21209,7 @@
                 </a:solidFill>
                 <a:latin typeface="Open Sans"/>
               </a:rPr>
-              <a:t>Komprise holds roughly three times the ranking keywords and five times the organic traffic of the nearest competitor, with the highest authority score in the set — and is the only company here that is both the largest and still growing. The three closest storage specialists all lost traffic this period.</a:t>
+              <a:t>Komprise holds roughly three times the ranking keywords and five times the organic traffic of the nearest competitor, with the highest authority score in the set. It is also the only company here that is both the largest and still growing. The three closest storage specialists all lost traffic this period.</a:t>
             </a:r>
           </a:p>
         </p:txBody>
@@ -21251,7 +21251,7 @@
                 </a:solidFill>
                 <a:latin typeface="Open Sans"/>
               </a:rPr>
-              <a:t>Komprise  —  GEO &amp; SEO Performance, Q2 2026</a:t>
+              <a:t>Komprise  ·  GEO &amp; SEO Performance, Q2 2026</a:t>
             </a:r>
           </a:p>
         </p:txBody>

</xml_diff>